<commit_message>
Improve dynamic document extraction and validation
</commit_message>
<xml_diff>
--- a/docs/solution_presentation.pptx
+++ b/docs/solution_presentation.pptx
@@ -3099,115 +3099,61 @@
       <p:grpSpPr/>
       <p:sp>
         <p:nvSpPr>
-          <p:cNvPr id="2" name="TextBox 1"/>
-          <p:cNvSpPr txBox="1"/>
-          <p:nvPr/>
-        </p:nvSpPr>
-        <p:spPr>
-          <a:xfrm>
-            <a:off x="548640" y="320040"/>
-            <a:ext cx="10972800" cy="640080"/>
-          </a:xfrm>
-          <a:prstGeom prst="rect">
-            <a:avLst/>
-          </a:prstGeom>
-          <a:noFill/>
-        </p:spPr>
-        <p:txBody>
-          <a:bodyPr wrap="none">
-            <a:spAutoFit/>
-          </a:bodyPr>
+          <p:cNvPr id="2" name="Title 1"/>
+          <p:cNvSpPr>
+            <a:spLocks noGrp="1"/>
+          </p:cNvSpPr>
+          <p:nvPr>
+            <p:ph type="ctrTitle"/>
+          </p:nvPr>
+        </p:nvSpPr>
+        <p:spPr/>
+        <p:txBody>
+          <a:bodyPr/>
+          <a:lstStyle/>
+          <a:p>
+            <a:r>
+              <a:t>Document Intelligence Platform</a:t>
+            </a:r>
+          </a:p>
+        </p:txBody>
+      </p:sp>
+      <p:sp>
+        <p:nvSpPr>
+          <p:cNvPr id="3" name="Subtitle 2"/>
+          <p:cNvSpPr>
+            <a:spLocks noGrp="1"/>
+          </p:cNvSpPr>
+          <p:nvPr>
+            <p:ph type="subTitle" idx="1"/>
+          </p:nvPr>
+        </p:nvSpPr>
+        <p:spPr/>
+        <p:txBody>
+          <a:bodyPr/>
           <a:lstStyle/>
           <a:p>
             <a:pPr>
-              <a:defRPr sz="2800" b="1"/>
+              <a:defRPr sz="2000"/>
             </a:pPr>
             <a:r>
-              <a:t>Intelligent Document Extraction, Validation &amp; API Platform</a:t>
-            </a:r>
-          </a:p>
-        </p:txBody>
-      </p:sp>
-      <p:sp>
-        <p:nvSpPr>
-          <p:cNvPr id="3" name="TextBox 2"/>
-          <p:cNvSpPr txBox="1"/>
-          <p:nvPr/>
-        </p:nvSpPr>
-        <p:spPr>
-          <a:xfrm>
-            <a:off x="566928" y="960120"/>
-            <a:ext cx="10789920" cy="411480"/>
-          </a:xfrm>
-          <a:prstGeom prst="rect">
-            <a:avLst/>
-          </a:prstGeom>
-          <a:noFill/>
-        </p:spPr>
-        <p:txBody>
-          <a:bodyPr wrap="none">
-            <a:spAutoFit/>
-          </a:bodyPr>
-          <a:lstStyle/>
+              <a:t>AI Engineer Internship Case Study</a:t>
+            </a:r>
+          </a:p>
           <a:p>
             <a:pPr>
-              <a:defRPr sz="1400"/>
+              <a:defRPr sz="1800"/>
             </a:pPr>
             <a:r>
-              <a:t>AI Engineer Internship — Technical Case Study</a:t>
-            </a:r>
-          </a:p>
-        </p:txBody>
-      </p:sp>
-      <p:sp>
-        <p:nvSpPr>
-          <p:cNvPr id="4" name="Rounded Rectangle 3"/>
-          <p:cNvSpPr/>
-          <p:nvPr/>
-        </p:nvSpPr>
-        <p:spPr>
-          <a:xfrm>
-            <a:off x="731520" y="1828800"/>
-            <a:ext cx="10698480" cy="2926080"/>
-          </a:xfrm>
-          <a:prstGeom prst="roundRect">
-            <a:avLst/>
-          </a:prstGeom>
-        </p:spPr>
-        <p:style>
-          <a:lnRef idx="1">
-            <a:schemeClr val="accent1"/>
-          </a:lnRef>
-          <a:fillRef idx="3">
-            <a:schemeClr val="accent1"/>
-          </a:fillRef>
-          <a:effectRef idx="2">
-            <a:schemeClr val="accent1"/>
-          </a:effectRef>
-          <a:fontRef idx="minor">
-            <a:schemeClr val="lt1"/>
-          </a:fontRef>
-        </p:style>
-        <p:txBody>
-          <a:bodyPr rtlCol="0" anchor="ctr"/>
-          <a:lstStyle/>
-          <a:p>
-            <a:pPr algn="ctr">
-              <a:spcAft>
-                <a:spcPts val="2000"/>
-              </a:spcAft>
-              <a:defRPr sz="3000" b="1"/>
+              <a:t>Dynamic extraction for Invoice, Balance Sheet, Profit &amp; Loss, and Cash Flow Statement.</a:t>
+            </a:r>
+          </a:p>
+          <a:p>
+            <a:pPr>
+              <a:defRPr sz="1800"/>
             </a:pPr>
             <a:r>
-              <a:t>Document Intelligence Platform</a:t>
-            </a:r>
-          </a:p>
-          <a:p>
-            <a:pPr algn="ctr">
-              <a:defRPr sz="2200"/>
-            </a:pPr>
-            <a:r>
-              <a:t>Invoice • Balance Sheet • Profit &amp; Loss • Cash Flow</a:t>
+              <a:t>OCR • 2-D layout • dynamic fields • grounded LLM • validation • SQLite • REST API • dashboard</a:t>
             </a:r>
           </a:p>
         </p:txBody>
@@ -3232,109 +3178,77 @@
       <p:grpSpPr/>
       <p:sp>
         <p:nvSpPr>
-          <p:cNvPr id="2" name="TextBox 1"/>
-          <p:cNvSpPr txBox="1"/>
-          <p:nvPr/>
-        </p:nvSpPr>
-        <p:spPr>
-          <a:xfrm>
-            <a:off x="548640" y="320040"/>
-            <a:ext cx="10972800" cy="640080"/>
-          </a:xfrm>
-          <a:prstGeom prst="rect">
-            <a:avLst/>
-          </a:prstGeom>
-          <a:noFill/>
-        </p:spPr>
-        <p:txBody>
-          <a:bodyPr wrap="none">
-            <a:spAutoFit/>
-          </a:bodyPr>
+          <p:cNvPr id="2" name="Title 1"/>
+          <p:cNvSpPr>
+            <a:spLocks noGrp="1"/>
+          </p:cNvSpPr>
+          <p:nvPr>
+            <p:ph type="title"/>
+          </p:nvPr>
+        </p:nvSpPr>
+        <p:spPr/>
+        <p:txBody>
+          <a:bodyPr/>
+          <a:lstStyle/>
+          <a:p>
+            <a:r>
+              <a:t>Deliverables</a:t>
+            </a:r>
+          </a:p>
+        </p:txBody>
+      </p:sp>
+      <p:sp>
+        <p:nvSpPr>
+          <p:cNvPr id="3" name="Content Placeholder 2"/>
+          <p:cNvSpPr>
+            <a:spLocks noGrp="1"/>
+          </p:cNvSpPr>
+          <p:nvPr>
+            <p:ph idx="1"/>
+          </p:nvPr>
+        </p:nvSpPr>
+        <p:spPr/>
+        <p:txBody>
+          <a:bodyPr/>
           <a:lstStyle/>
           <a:p>
             <a:pPr>
-              <a:defRPr sz="2800" b="1"/>
+              <a:defRPr sz="1800"/>
             </a:pPr>
             <a:r>
-              <a:t>9. Deployment &amp; Next Steps</a:t>
-            </a:r>
-          </a:p>
-        </p:txBody>
-      </p:sp>
-      <p:sp>
-        <p:nvSpPr>
-          <p:cNvPr id="3" name="TextBox 2"/>
-          <p:cNvSpPr txBox="1"/>
-          <p:nvPr/>
-        </p:nvSpPr>
-        <p:spPr>
-          <a:xfrm>
-            <a:off x="731520" y="1371600"/>
-            <a:ext cx="10789920" cy="4754880"/>
-          </a:xfrm>
-          <a:prstGeom prst="rect">
-            <a:avLst/>
-          </a:prstGeom>
-          <a:noFill/>
-        </p:spPr>
-        <p:txBody>
-          <a:bodyPr wrap="square">
-            <a:spAutoFit/>
-          </a:bodyPr>
-          <a:lstStyle/>
+              <a:t>Dynamic source code and layout-aware OCR</a:t>
+            </a:r>
+          </a:p>
           <a:p>
             <a:pPr>
-              <a:spcAft>
-                <a:spcPts val="1000"/>
-              </a:spcAft>
-              <a:defRPr sz="2000"/>
+              <a:defRPr sz="1800"/>
             </a:pPr>
             <a:r>
-              <a:t>Dockerfile and Render configuration are included.</a:t>
+              <a:t>Architecture diagram and technical audit</a:t>
             </a:r>
           </a:p>
           <a:p>
             <a:pPr>
-              <a:spcAft>
-                <a:spcPts val="1000"/>
-              </a:spcAft>
-              <a:defRPr sz="2000"/>
+              <a:defRPr sz="1800"/>
             </a:pPr>
             <a:r>
-              <a:t>Set HUGGINGFACE_API_KEY only in the deployment platform secret/environment settings.</a:t>
+              <a:t>Solution presentation (PPTX and PDF)</a:t>
             </a:r>
           </a:p>
           <a:p>
             <a:pPr>
-              <a:spcAft>
-                <a:spcPts val="1000"/>
-              </a:spcAft>
-              <a:defRPr sz="2000"/>
+              <a:defRPr sz="1800"/>
             </a:pPr>
             <a:r>
-              <a:t>Verify live frontend, API, Swagger, health, upload, persistence, and GET-by-name flows.</a:t>
+              <a:t>Automated tests</a:t>
             </a:r>
           </a:p>
           <a:p>
             <a:pPr>
-              <a:spcAft>
-                <a:spcPts val="1000"/>
-              </a:spcAft>
-              <a:defRPr sz="2000"/>
+              <a:defRPr sz="1800"/>
             </a:pPr>
             <a:r>
-              <a:t>Before submission, publish the repository and replace the README deployment placeholders with live URLs.</a:t>
-            </a:r>
-          </a:p>
-          <a:p>
-            <a:pPr>
-              <a:spcAft>
-                <a:spcPts val="1000"/>
-              </a:spcAft>
-              <a:defRPr sz="2000"/>
-            </a:pPr>
-            <a:r>
-              <a:t>Be ready to explain OCR, extraction prompts, validation formulas, database design, deployment, and debugging.</a:t>
+              <a:t>README with setup, API, validation, and deployment guidance</a:t>
             </a:r>
           </a:p>
         </p:txBody>
@@ -3359,98 +3273,61 @@
       <p:grpSpPr/>
       <p:sp>
         <p:nvSpPr>
-          <p:cNvPr id="2" name="TextBox 1"/>
-          <p:cNvSpPr txBox="1"/>
-          <p:nvPr/>
-        </p:nvSpPr>
-        <p:spPr>
-          <a:xfrm>
-            <a:off x="548640" y="320040"/>
-            <a:ext cx="10972800" cy="640080"/>
-          </a:xfrm>
-          <a:prstGeom prst="rect">
-            <a:avLst/>
-          </a:prstGeom>
-          <a:noFill/>
-        </p:spPr>
-        <p:txBody>
-          <a:bodyPr wrap="none">
-            <a:spAutoFit/>
-          </a:bodyPr>
+          <p:cNvPr id="2" name="Title 1"/>
+          <p:cNvSpPr>
+            <a:spLocks noGrp="1"/>
+          </p:cNvSpPr>
+          <p:nvPr>
+            <p:ph type="title"/>
+          </p:nvPr>
+        </p:nvSpPr>
+        <p:spPr/>
+        <p:txBody>
+          <a:bodyPr/>
+          <a:lstStyle/>
+          <a:p>
+            <a:r>
+              <a:t>Problem and design goal</a:t>
+            </a:r>
+          </a:p>
+        </p:txBody>
+      </p:sp>
+      <p:sp>
+        <p:nvSpPr>
+          <p:cNvPr id="3" name="Content Placeholder 2"/>
+          <p:cNvSpPr>
+            <a:spLocks noGrp="1"/>
+          </p:cNvSpPr>
+          <p:nvPr>
+            <p:ph idx="1"/>
+          </p:nvPr>
+        </p:nvSpPr>
+        <p:spPr/>
+        <p:txBody>
+          <a:bodyPr/>
           <a:lstStyle/>
           <a:p>
             <a:pPr>
-              <a:defRPr sz="2800" b="1"/>
+              <a:defRPr sz="1800"/>
             </a:pPr>
             <a:r>
-              <a:t>1. Problem &amp; Objective</a:t>
-            </a:r>
-          </a:p>
-        </p:txBody>
-      </p:sp>
-      <p:sp>
-        <p:nvSpPr>
-          <p:cNvPr id="3" name="TextBox 2"/>
-          <p:cNvSpPr txBox="1"/>
-          <p:nvPr/>
-        </p:nvSpPr>
-        <p:spPr>
-          <a:xfrm>
-            <a:off x="731520" y="1371600"/>
-            <a:ext cx="10789920" cy="4754880"/>
-          </a:xfrm>
-          <a:prstGeom prst="rect">
-            <a:avLst/>
-          </a:prstGeom>
-          <a:noFill/>
-        </p:spPr>
-        <p:txBody>
-          <a:bodyPr wrap="square">
-            <a:spAutoFit/>
-          </a:bodyPr>
-          <a:lstStyle/>
+              <a:t>Avoid vendor/template-specific parsers and growing regex/if-else rules.</a:t>
+            </a:r>
+          </a:p>
           <a:p>
             <a:pPr>
-              <a:spcAft>
-                <a:spcPts val="1000"/>
-              </a:spcAft>
-              <a:defRPr sz="2000"/>
+              <a:defRPr sz="1800"/>
             </a:pPr>
             <a:r>
-              <a:t>Automate extraction from native and scanned financial documents.</a:t>
+              <a:t>Handle different labels, layouts, table positions, headers, footers, and wrapped descriptions.</a:t>
             </a:r>
           </a:p>
           <a:p>
             <a:pPr>
-              <a:spcAft>
-                <a:spcPts val="1000"/>
-              </a:spcAft>
-              <a:defRPr sz="2000"/>
+              <a:defRPr sz="1800"/>
             </a:pPr>
             <a:r>
-              <a:t>Return complete, structured key-value and table data with evidence.</a:t>
-            </a:r>
-          </a:p>
-          <a:p>
-            <a:pPr>
-              <a:spcAft>
-                <a:spcPts val="1000"/>
-              </a:spcAft>
-              <a:defRPr sz="2000"/>
-            </a:pPr>
-            <a:r>
-              <a:t>Validate financial relationships without inventing missing values.</a:t>
-            </a:r>
-          </a:p>
-          <a:p>
-            <a:pPr>
-              <a:spcAft>
-                <a:spcPts val="1000"/>
-              </a:spcAft>
-              <a:defRPr sz="2000"/>
-            </a:pPr>
-            <a:r>
-              <a:t>Persist results and expose them through a deployed dashboard and REST APIs.</a:t>
+              <a:t>Separate document processing status from financial validation status.</a:t>
             </a:r>
           </a:p>
         </p:txBody>
@@ -3475,98 +3352,53 @@
       <p:grpSpPr/>
       <p:sp>
         <p:nvSpPr>
-          <p:cNvPr id="2" name="TextBox 1"/>
-          <p:cNvSpPr txBox="1"/>
-          <p:nvPr/>
-        </p:nvSpPr>
-        <p:spPr>
-          <a:xfrm>
-            <a:off x="548640" y="320040"/>
-            <a:ext cx="10972800" cy="640080"/>
-          </a:xfrm>
-          <a:prstGeom prst="rect">
-            <a:avLst/>
-          </a:prstGeom>
-          <a:noFill/>
-        </p:spPr>
-        <p:txBody>
-          <a:bodyPr wrap="none">
-            <a:spAutoFit/>
-          </a:bodyPr>
+          <p:cNvPr id="2" name="Title 1"/>
+          <p:cNvSpPr>
+            <a:spLocks noGrp="1"/>
+          </p:cNvSpPr>
+          <p:nvPr>
+            <p:ph type="title"/>
+          </p:nvPr>
+        </p:nvSpPr>
+        <p:spPr/>
+        <p:txBody>
+          <a:bodyPr/>
+          <a:lstStyle/>
+          <a:p>
+            <a:r>
+              <a:t>Dynamic processing pipeline</a:t>
+            </a:r>
+          </a:p>
+        </p:txBody>
+      </p:sp>
+      <p:sp>
+        <p:nvSpPr>
+          <p:cNvPr id="3" name="Content Placeholder 2"/>
+          <p:cNvSpPr>
+            <a:spLocks noGrp="1"/>
+          </p:cNvSpPr>
+          <p:nvPr>
+            <p:ph idx="1"/>
+          </p:nvPr>
+        </p:nvSpPr>
+        <p:spPr/>
+        <p:txBody>
+          <a:bodyPr/>
           <a:lstStyle/>
           <a:p>
             <a:pPr>
-              <a:defRPr sz="2800" b="1"/>
+              <a:defRPr sz="1800"/>
             </a:pPr>
             <a:r>
-              <a:t>2. End-to-End Architecture</a:t>
-            </a:r>
-          </a:p>
-        </p:txBody>
-      </p:sp>
-      <p:sp>
-        <p:nvSpPr>
-          <p:cNvPr id="3" name="TextBox 2"/>
-          <p:cNvSpPr txBox="1"/>
-          <p:nvPr/>
-        </p:nvSpPr>
-        <p:spPr>
-          <a:xfrm>
-            <a:off x="731520" y="1371600"/>
-            <a:ext cx="10789920" cy="4754880"/>
-          </a:xfrm>
-          <a:prstGeom prst="rect">
-            <a:avLst/>
-          </a:prstGeom>
-          <a:noFill/>
-        </p:spPr>
-        <p:txBody>
-          <a:bodyPr wrap="square">
-            <a:spAutoFit/>
-          </a:bodyPr>
-          <a:lstStyle/>
+              <a:t>Upload → file validation → native text/OCR → 2-D layout extraction → dynamic semantic extraction → evidence verification → financial validation → persistence → dashboard/API</a:t>
+            </a:r>
+          </a:p>
           <a:p>
             <a:pPr>
-              <a:spcAft>
-                <a:spcPts val="1000"/>
-              </a:spcAft>
-              <a:defRPr sz="2000"/>
+              <a:defRPr sz="1800"/>
             </a:pPr>
             <a:r>
-              <a:t>Upload → File Validation → Native Text / Tesseract OCR</a:t>
-            </a:r>
-          </a:p>
-          <a:p>
-            <a:pPr>
-              <a:spcAft>
-                <a:spcPts val="1000"/>
-              </a:spcAft>
-              <a:defRPr sz="2000"/>
-            </a:pPr>
-            <a:r>
-              <a:t>Structured Extraction → Evidence / Page Grounding</a:t>
-            </a:r>
-          </a:p>
-          <a:p>
-            <a:pPr>
-              <a:spcAft>
-                <a:spcPts val="1000"/>
-              </a:spcAft>
-              <a:defRPr sz="2000"/>
-            </a:pPr>
-            <a:r>
-              <a:t>Financial Validation → Persistence (SQLAlchemy / SQLite)</a:t>
-            </a:r>
-          </a:p>
-          <a:p>
-            <a:pPr>
-              <a:spcAft>
-                <a:spcPts val="1000"/>
-              </a:spcAft>
-              <a:defRPr sz="2000"/>
-            </a:pPr>
-            <a:r>
-              <a:t>Dashboard + REST API + Swagger/OpenAPI</a:t>
+              <a:t>OCR retains word coordinates so invoice columns are not flattened into a single text stream.</a:t>
             </a:r>
           </a:p>
         </p:txBody>
@@ -3591,109 +3423,61 @@
       <p:grpSpPr/>
       <p:sp>
         <p:nvSpPr>
-          <p:cNvPr id="2" name="TextBox 1"/>
-          <p:cNvSpPr txBox="1"/>
-          <p:nvPr/>
-        </p:nvSpPr>
-        <p:spPr>
-          <a:xfrm>
-            <a:off x="548640" y="320040"/>
-            <a:ext cx="10972800" cy="640080"/>
-          </a:xfrm>
-          <a:prstGeom prst="rect">
-            <a:avLst/>
-          </a:prstGeom>
-          <a:noFill/>
-        </p:spPr>
-        <p:txBody>
-          <a:bodyPr wrap="none">
-            <a:spAutoFit/>
-          </a:bodyPr>
+          <p:cNvPr id="2" name="Title 1"/>
+          <p:cNvSpPr>
+            <a:spLocks noGrp="1"/>
+          </p:cNvSpPr>
+          <p:nvPr>
+            <p:ph type="title"/>
+          </p:nvPr>
+        </p:nvSpPr>
+        <p:spPr/>
+        <p:txBody>
+          <a:bodyPr/>
+          <a:lstStyle/>
+          <a:p>
+            <a:r>
+              <a:t>Layout-aware invoice extraction</a:t>
+            </a:r>
+          </a:p>
+        </p:txBody>
+      </p:sp>
+      <p:sp>
+        <p:nvSpPr>
+          <p:cNvPr id="3" name="Content Placeholder 2"/>
+          <p:cNvSpPr>
+            <a:spLocks noGrp="1"/>
+          </p:cNvSpPr>
+          <p:nvPr>
+            <p:ph idx="1"/>
+          </p:nvPr>
+        </p:nvSpPr>
+        <p:spPr/>
+        <p:txBody>
+          <a:bodyPr/>
           <a:lstStyle/>
           <a:p>
             <a:pPr>
-              <a:defRPr sz="2800" b="1"/>
+              <a:defRPr sz="1800"/>
             </a:pPr>
             <a:r>
-              <a:t>3. Extraction Strategy</a:t>
-            </a:r>
-          </a:p>
-        </p:txBody>
-      </p:sp>
-      <p:sp>
-        <p:nvSpPr>
-          <p:cNvPr id="3" name="TextBox 2"/>
-          <p:cNvSpPr txBox="1"/>
-          <p:nvPr/>
-        </p:nvSpPr>
-        <p:spPr>
-          <a:xfrm>
-            <a:off x="731520" y="1371600"/>
-            <a:ext cx="10789920" cy="4754880"/>
-          </a:xfrm>
-          <a:prstGeom prst="rect">
-            <a:avLst/>
-          </a:prstGeom>
-          <a:noFill/>
-        </p:spPr>
-        <p:txBody>
-          <a:bodyPr wrap="square">
-            <a:spAutoFit/>
-          </a:bodyPr>
-          <a:lstStyle/>
+              <a:t>Infer Description / Quantity / Unit Price / Amount columns from actual header positions.</a:t>
+            </a:r>
+          </a:p>
           <a:p>
             <a:pPr>
-              <a:spcAft>
-                <a:spcPts val="1000"/>
-              </a:spcAft>
-              <a:defRPr sz="2000"/>
+              <a:defRPr sz="1800"/>
             </a:pPr>
             <a:r>
-              <a:t>PDF text is used when the page contains sufficient native text.</a:t>
+              <a:t>Numbers inside product descriptions such as 3M 570, 12oz, and 100/BX remain in the description column.</a:t>
             </a:r>
           </a:p>
           <a:p>
             <a:pPr>
-              <a:spcAft>
-                <a:spcPts val="1000"/>
-              </a:spcAft>
-              <a:defRPr sz="2000"/>
+              <a:defRPr sz="1800"/>
             </a:pPr>
             <a:r>
-              <a:t>Scanned pages are rendered at 300 DPI and processed with Tesseract PSM 4.</a:t>
-            </a:r>
-          </a:p>
-          <a:p>
-            <a:pPr>
-              <a:spcAft>
-                <a:spcPts val="1000"/>
-              </a:spcAft>
-              <a:defRPr sz="2000"/>
-            </a:pPr>
-            <a:r>
-              <a:t>Balance Sheet scans use deterministic table parsing because annual-report columns are highly structured.</a:t>
-            </a:r>
-          </a:p>
-          <a:p>
-            <a:pPr>
-              <a:spcAft>
-                <a:spcPts val="1000"/>
-              </a:spcAft>
-              <a:defRPr sz="2000"/>
-            </a:pPr>
-            <a:r>
-              <a:t>LLM extraction remains available for other document types through an OpenAI-compatible provider.</a:t>
-            </a:r>
-          </a:p>
-          <a:p>
-            <a:pPr>
-              <a:spcAft>
-                <a:spcPts val="1000"/>
-              </a:spcAft>
-              <a:defRPr sz="2000"/>
-            </a:pPr>
-            <a:r>
-              <a:t>Fallback extraction reads only OCR/document text — never the extraction prompt or schema.</a:t>
+              <a:t>Wrapped description rows can be buffered and merged without stealing values from adjacent numeric columns.</a:t>
             </a:r>
           </a:p>
         </p:txBody>
@@ -3718,109 +3502,69 @@
       <p:grpSpPr/>
       <p:sp>
         <p:nvSpPr>
-          <p:cNvPr id="2" name="TextBox 1"/>
-          <p:cNvSpPr txBox="1"/>
-          <p:nvPr/>
-        </p:nvSpPr>
-        <p:spPr>
-          <a:xfrm>
-            <a:off x="548640" y="320040"/>
-            <a:ext cx="10972800" cy="640080"/>
-          </a:xfrm>
-          <a:prstGeom prst="rect">
-            <a:avLst/>
-          </a:prstGeom>
-          <a:noFill/>
-        </p:spPr>
-        <p:txBody>
-          <a:bodyPr wrap="none">
-            <a:spAutoFit/>
-          </a:bodyPr>
+          <p:cNvPr id="2" name="Title 1"/>
+          <p:cNvSpPr>
+            <a:spLocks noGrp="1"/>
+          </p:cNvSpPr>
+          <p:nvPr>
+            <p:ph type="title"/>
+          </p:nvPr>
+        </p:nvSpPr>
+        <p:spPr/>
+        <p:txBody>
+          <a:bodyPr/>
+          <a:lstStyle/>
+          <a:p>
+            <a:r>
+              <a:t>Dynamic fields and LLM grounding</a:t>
+            </a:r>
+          </a:p>
+        </p:txBody>
+      </p:sp>
+      <p:sp>
+        <p:nvSpPr>
+          <p:cNvPr id="3" name="Content Placeholder 2"/>
+          <p:cNvSpPr>
+            <a:spLocks noGrp="1"/>
+          </p:cNvSpPr>
+          <p:nvPr>
+            <p:ph idx="1"/>
+          </p:nvPr>
+        </p:nvSpPr>
+        <p:spPr/>
+        <p:txBody>
+          <a:bodyPr/>
           <a:lstStyle/>
           <a:p>
             <a:pPr>
-              <a:defRPr sz="2800" b="1"/>
+              <a:defRPr sz="1800"/>
             </a:pPr>
             <a:r>
-              <a:t>4. Debugging the Original Failure</a:t>
-            </a:r>
-          </a:p>
-        </p:txBody>
-      </p:sp>
-      <p:sp>
-        <p:nvSpPr>
-          <p:cNvPr id="3" name="TextBox 2"/>
-          <p:cNvSpPr txBox="1"/>
-          <p:nvPr/>
-        </p:nvSpPr>
-        <p:spPr>
-          <a:xfrm>
-            <a:off x="731520" y="1371600"/>
-            <a:ext cx="10789920" cy="4754880"/>
-          </a:xfrm>
-          <a:prstGeom prst="rect">
-            <a:avLst/>
-          </a:prstGeom>
-          <a:noFill/>
-        </p:spPr>
-        <p:txBody>
-          <a:bodyPr wrap="square">
-            <a:spAutoFit/>
-          </a:bodyPr>
-          <a:lstStyle/>
+              <a:t>Canonical fields support required financial validation concepts.</a:t>
+            </a:r>
+          </a:p>
           <a:p>
             <a:pPr>
-              <a:spcAft>
-                <a:spcPts val="1000"/>
-              </a:spcAft>
-              <a:defRPr sz="2000"/>
+              <a:defRPr sz="1800"/>
             </a:pPr>
             <a:r>
-              <a:t>Original fallback regex searched the complete LLM prompt.</a:t>
+              <a:t>Unknown meaningful fields are preserved in discovered_fields.</a:t>
             </a:r>
           </a:p>
           <a:p>
             <a:pPr>
-              <a:spcAft>
-                <a:spcPts val="1000"/>
-              </a:spcAft>
-              <a:defRPr sz="2000"/>
+              <a:defRPr sz="1800"/>
             </a:pPr>
             <a:r>
-              <a:t>Schema/schedule text such as “assets 10” and “liabilities 12” became fake financial values.</a:t>
+              <a:t>LLM receives the full OCR document, including header, right-side content, footer, and all pages.</a:t>
             </a:r>
           </a:p>
           <a:p>
             <a:pPr>
-              <a:spcAft>
-                <a:spcPts val="1000"/>
-              </a:spcAft>
-              <a:defRPr sz="2000"/>
+              <a:defRPr sz="1800"/>
             </a:pPr>
             <a:r>
-              <a:t>Signature text was incorrectly captured as customer_name.</a:t>
-            </a:r>
-          </a:p>
-          <a:p>
-            <a:pPr>
-              <a:spcAft>
-                <a:spcPts val="1000"/>
-              </a:spcAft>
-              <a:defRPr sz="2000"/>
-            </a:pPr>
-            <a:r>
-              <a:t>The fix isolates OCR text from prompt text and adds document-type-aware table parsing.</a:t>
-            </a:r>
-          </a:p>
-          <a:p>
-            <a:pPr>
-              <a:spcAft>
-                <a:spcPts val="1000"/>
-              </a:spcAft>
-              <a:defRPr sz="2000"/>
-            </a:pPr>
-            <a:r>
-              <a:t>A regression test now prevents prompt-derived financial values.</a:t>
+              <a:t>LLM values are accepted only when grounded in supplied OCR evidence.</a:t>
             </a:r>
           </a:p>
         </p:txBody>
@@ -3845,109 +3589,69 @@
       <p:grpSpPr/>
       <p:sp>
         <p:nvSpPr>
-          <p:cNvPr id="2" name="TextBox 1"/>
-          <p:cNvSpPr txBox="1"/>
-          <p:nvPr/>
-        </p:nvSpPr>
-        <p:spPr>
-          <a:xfrm>
-            <a:off x="548640" y="320040"/>
-            <a:ext cx="10972800" cy="640080"/>
-          </a:xfrm>
-          <a:prstGeom prst="rect">
-            <a:avLst/>
-          </a:prstGeom>
-          <a:noFill/>
-        </p:spPr>
-        <p:txBody>
-          <a:bodyPr wrap="none">
-            <a:spAutoFit/>
-          </a:bodyPr>
+          <p:cNvPr id="2" name="Title 1"/>
+          <p:cNvSpPr>
+            <a:spLocks noGrp="1"/>
+          </p:cNvSpPr>
+          <p:nvPr>
+            <p:ph type="title"/>
+          </p:nvPr>
+        </p:nvSpPr>
+        <p:spPr/>
+        <p:txBody>
+          <a:bodyPr/>
+          <a:lstStyle/>
+          <a:p>
+            <a:r>
+              <a:t>Invoice validation</a:t>
+            </a:r>
+          </a:p>
+        </p:txBody>
+      </p:sp>
+      <p:sp>
+        <p:nvSpPr>
+          <p:cNvPr id="3" name="Content Placeholder 2"/>
+          <p:cNvSpPr>
+            <a:spLocks noGrp="1"/>
+          </p:cNvSpPr>
+          <p:nvPr>
+            <p:ph idx="1"/>
+          </p:nvPr>
+        </p:nvSpPr>
+        <p:spPr/>
+        <p:txBody>
+          <a:bodyPr/>
           <a:lstStyle/>
           <a:p>
             <a:pPr>
-              <a:defRPr sz="2800" b="1"/>
+              <a:defRPr sz="1800"/>
             </a:pPr>
             <a:r>
-              <a:t>5. Financial Validation</a:t>
-            </a:r>
-          </a:p>
-        </p:txBody>
-      </p:sp>
-      <p:sp>
-        <p:nvSpPr>
-          <p:cNvPr id="3" name="TextBox 2"/>
-          <p:cNvSpPr txBox="1"/>
-          <p:nvPr/>
-        </p:nvSpPr>
-        <p:spPr>
-          <a:xfrm>
-            <a:off x="731520" y="1371600"/>
-            <a:ext cx="10789920" cy="4754880"/>
-          </a:xfrm>
-          <a:prstGeom prst="rect">
-            <a:avLst/>
-          </a:prstGeom>
-          <a:noFill/>
-        </p:spPr>
-        <p:txBody>
-          <a:bodyPr wrap="square">
-            <a:spAutoFit/>
-          </a:bodyPr>
-          <a:lstStyle/>
+              <a:t>Total formula: subtotal + tax + shipping/handling/other charges − discount ≈ total.</a:t>
+            </a:r>
+          </a:p>
           <a:p>
             <a:pPr>
-              <a:spcAft>
-                <a:spcPts val="1000"/>
-              </a:spcAft>
-              <a:defRPr sz="2000"/>
+              <a:defRPr sz="1800"/>
             </a:pPr>
             <a:r>
-              <a:t>Balance Sheet: Total Capital &amp; Liabilities ≈ Total Assets, independently per period.</a:t>
+              <a:t>Line-item quantity × unit price ≈ amount.</a:t>
             </a:r>
           </a:p>
           <a:p>
             <a:pPr>
-              <a:spcAft>
-                <a:spcPts val="1000"/>
-              </a:spcAft>
-              <a:defRPr sz="2000"/>
+              <a:defRPr sz="1800"/>
             </a:pPr>
             <a:r>
-              <a:t>Invoice: line calculations and subtotal/tax/discount/total reconciliation, including explicit tax-included cases.</a:t>
+              <a:t>Line-item sum ≈ subtotal.</a:t>
             </a:r>
           </a:p>
           <a:p>
             <a:pPr>
-              <a:spcAft>
-                <a:spcPts val="1000"/>
-              </a:spcAft>
-              <a:defRPr sz="2000"/>
+              <a:defRPr sz="1800"/>
             </a:pPr>
             <a:r>
-              <a:t>Profit &amp; Loss: the five formulas specified by the case study.</a:t>
-            </a:r>
-          </a:p>
-          <a:p>
-            <a:pPr>
-              <a:spcAft>
-                <a:spcPts val="1000"/>
-              </a:spcAft>
-              <a:defRPr sz="2000"/>
-            </a:pPr>
-            <a:r>
-              <a:t>Cash Flow: operating + investing + financing + FX adjustment, then opening + net change + applicable adjustments.</a:t>
-            </a:r>
-          </a:p>
-          <a:p>
-            <a:pPr>
-              <a:spcAft>
-                <a:spcPts val="1000"/>
-              </a:spcAft>
-              <a:defRPr sz="2000"/>
-            </a:pPr>
-            <a:r>
-              <a:t>Missing operands produce NOT_APPLICABLE; values are never fabricated.</a:t>
+              <a:t>Validation discrepancies are isolated in validation.overall_status; a successfully parsed document remains processing_status = PASS.</a:t>
             </a:r>
           </a:p>
         </p:txBody>
@@ -3972,109 +3676,61 @@
       <p:grpSpPr/>
       <p:sp>
         <p:nvSpPr>
-          <p:cNvPr id="2" name="TextBox 1"/>
-          <p:cNvSpPr txBox="1"/>
-          <p:nvPr/>
-        </p:nvSpPr>
-        <p:spPr>
-          <a:xfrm>
-            <a:off x="548640" y="320040"/>
-            <a:ext cx="10972800" cy="640080"/>
-          </a:xfrm>
-          <a:prstGeom prst="rect">
-            <a:avLst/>
-          </a:prstGeom>
-          <a:noFill/>
-        </p:spPr>
-        <p:txBody>
-          <a:bodyPr wrap="none">
-            <a:spAutoFit/>
-          </a:bodyPr>
+          <p:cNvPr id="2" name="Title 1"/>
+          <p:cNvSpPr>
+            <a:spLocks noGrp="1"/>
+          </p:cNvSpPr>
+          <p:nvPr>
+            <p:ph type="title"/>
+          </p:nvPr>
+        </p:nvSpPr>
+        <p:spPr/>
+        <p:txBody>
+          <a:bodyPr/>
+          <a:lstStyle/>
+          <a:p>
+            <a:r>
+              <a:t>Statement validation</a:t>
+            </a:r>
+          </a:p>
+        </p:txBody>
+      </p:sp>
+      <p:sp>
+        <p:nvSpPr>
+          <p:cNvPr id="3" name="Content Placeholder 2"/>
+          <p:cNvSpPr>
+            <a:spLocks noGrp="1"/>
+          </p:cNvSpPr>
+          <p:nvPr>
+            <p:ph idx="1"/>
+          </p:nvPr>
+        </p:nvSpPr>
+        <p:spPr/>
+        <p:txBody>
+          <a:bodyPr/>
           <a:lstStyle/>
           <a:p>
             <a:pPr>
-              <a:defRPr sz="2800" b="1"/>
+              <a:defRPr sz="1800"/>
             </a:pPr>
             <a:r>
-              <a:t>6. Supplied Balance Sheet Verification</a:t>
-            </a:r>
-          </a:p>
-        </p:txBody>
-      </p:sp>
-      <p:sp>
-        <p:nvSpPr>
-          <p:cNvPr id="3" name="TextBox 2"/>
-          <p:cNvSpPr txBox="1"/>
-          <p:nvPr/>
-        </p:nvSpPr>
-        <p:spPr>
-          <a:xfrm>
-            <a:off x="731520" y="1371600"/>
-            <a:ext cx="10789920" cy="4754880"/>
-          </a:xfrm>
-          <a:prstGeom prst="rect">
-            <a:avLst/>
-          </a:prstGeom>
-          <a:noFill/>
-        </p:spPr>
-        <p:txBody>
-          <a:bodyPr wrap="square">
-            <a:spAutoFit/>
-          </a:bodyPr>
-          <a:lstStyle/>
+              <a:t>Balance Sheet: total capital/liabilities ≈ total assets; component reconciliations where sufficient data exists.</a:t>
+            </a:r>
+          </a:p>
           <a:p>
             <a:pPr>
-              <a:spcAft>
-                <a:spcPts val="1000"/>
-              </a:spcAft>
-              <a:defRPr sz="2000"/>
+              <a:defRPr sz="1800"/>
             </a:pPr>
             <a:r>
-              <a:t>2017: 8,923,441,607 = 8,923,441,607 — PASS</a:t>
+              <a:t>P&amp;L: assignment formulas for bank-style and generic statements.</a:t>
             </a:r>
           </a:p>
           <a:p>
             <a:pPr>
-              <a:spcAft>
-                <a:spcPts val="1000"/>
-              </a:spcAft>
-              <a:defRPr sz="2000"/>
+              <a:defRPr sz="1800"/>
             </a:pPr>
             <a:r>
-              <a:t>2018: 11,031,861,695 = 11,031,861,695 — PASS</a:t>
-            </a:r>
-          </a:p>
-          <a:p>
-            <a:pPr>
-              <a:spcAft>
-                <a:spcPts val="1000"/>
-              </a:spcAft>
-              <a:defRPr sz="2000"/>
-            </a:pPr>
-            <a:r>
-              <a:t>2019: 12,928,057,065 = 12,928,057,065 — PASS</a:t>
-            </a:r>
-          </a:p>
-          <a:p>
-            <a:pPr>
-              <a:spcAft>
-                <a:spcPts val="1000"/>
-              </a:spcAft>
-              <a:defRPr sz="2000"/>
-            </a:pPr>
-            <a:r>
-              <a:t>2020: 15,808,304,373 = 15,808,304,373 — PASS</a:t>
-            </a:r>
-          </a:p>
-          <a:p>
-            <a:pPr>
-              <a:spcAft>
-                <a:spcPts val="1000"/>
-              </a:spcAft>
-              <a:defRPr sz="2000"/>
-            </a:pPr>
-            <a:r>
-              <a:t>2021: 17,995,066,442 = 17,995,066,442 — PASS</a:t>
+              <a:t>Cash Flow: operating + investing + financing + FX ≈ net change; opening + net change + adjustments ≈ closing.</a:t>
             </a:r>
           </a:p>
         </p:txBody>
@@ -4099,109 +3755,69 @@
       <p:grpSpPr/>
       <p:sp>
         <p:nvSpPr>
-          <p:cNvPr id="2" name="TextBox 1"/>
-          <p:cNvSpPr txBox="1"/>
-          <p:nvPr/>
-        </p:nvSpPr>
-        <p:spPr>
-          <a:xfrm>
-            <a:off x="548640" y="320040"/>
-            <a:ext cx="10972800" cy="640080"/>
-          </a:xfrm>
-          <a:prstGeom prst="rect">
-            <a:avLst/>
-          </a:prstGeom>
-          <a:noFill/>
-        </p:spPr>
-        <p:txBody>
-          <a:bodyPr wrap="none">
-            <a:spAutoFit/>
-          </a:bodyPr>
+          <p:cNvPr id="2" name="Title 1"/>
+          <p:cNvSpPr>
+            <a:spLocks noGrp="1"/>
+          </p:cNvSpPr>
+          <p:nvPr>
+            <p:ph type="title"/>
+          </p:nvPr>
+        </p:nvSpPr>
+        <p:spPr/>
+        <p:txBody>
+          <a:bodyPr/>
+          <a:lstStyle/>
+          <a:p>
+            <a:r>
+              <a:t>API, frontend and persistence</a:t>
+            </a:r>
+          </a:p>
+        </p:txBody>
+      </p:sp>
+      <p:sp>
+        <p:nvSpPr>
+          <p:cNvPr id="3" name="Content Placeholder 2"/>
+          <p:cNvSpPr>
+            <a:spLocks noGrp="1"/>
+          </p:cNvSpPr>
+          <p:nvPr>
+            <p:ph idx="1"/>
+          </p:nvPr>
+        </p:nvSpPr>
+        <p:spPr/>
+        <p:txBody>
+          <a:bodyPr/>
           <a:lstStyle/>
           <a:p>
             <a:pPr>
-              <a:defRPr sz="2800" b="1"/>
+              <a:defRPr sz="1800"/>
             </a:pPr>
             <a:r>
-              <a:t>7. API &amp; Frontend</a:t>
-            </a:r>
-          </a:p>
-        </p:txBody>
-      </p:sp>
-      <p:sp>
-        <p:nvSpPr>
-          <p:cNvPr id="3" name="TextBox 2"/>
-          <p:cNvSpPr txBox="1"/>
-          <p:nvPr/>
-        </p:nvSpPr>
-        <p:spPr>
-          <a:xfrm>
-            <a:off x="731520" y="1371600"/>
-            <a:ext cx="10789920" cy="4754880"/>
-          </a:xfrm>
-          <a:prstGeom prst="rect">
-            <a:avLst/>
-          </a:prstGeom>
-          <a:noFill/>
-        </p:spPr>
-        <p:txBody>
-          <a:bodyPr wrap="square">
-            <a:spAutoFit/>
-          </a:bodyPr>
-          <a:lstStyle/>
+              <a:t>FastAPI REST endpoints for process, list, detail, and health.</a:t>
+            </a:r>
+          </a:p>
           <a:p>
             <a:pPr>
-              <a:spcAft>
-                <a:spcPts val="1000"/>
-              </a:spcAft>
-              <a:defRPr sz="2000"/>
+              <a:defRPr sz="1800"/>
             </a:pPr>
             <a:r>
-              <a:t>POST /api/v1/documents/process — multipart upload + document type</a:t>
+              <a:t>SQLite persistence for processed results.</a:t>
             </a:r>
           </a:p>
           <a:p>
             <a:pPr>
-              <a:spcAft>
-                <a:spcPts val="1000"/>
-              </a:spcAft>
-              <a:defRPr sz="2000"/>
+              <a:defRPr sz="1800"/>
             </a:pPr>
             <a:r>
-              <a:t>GET /api/v1/documents/{document_name} — latest persisted result</a:t>
+              <a:t>Dashboard shows extracted fields, evidence, discovered fields, line items, validation checks, and raw JSON.</a:t>
             </a:r>
           </a:p>
           <a:p>
             <a:pPr>
-              <a:spcAft>
-                <a:spcPts val="1000"/>
-              </a:spcAft>
-              <a:defRPr sz="2000"/>
+              <a:defRPr sz="1800"/>
             </a:pPr>
             <a:r>
-              <a:t>GET /api/v1/documents — dashboard records</a:t>
-            </a:r>
-          </a:p>
-          <a:p>
-            <a:pPr>
-              <a:spcAft>
-                <a:spcPts val="1000"/>
-              </a:spcAft>
-              <a:defRPr sz="2000"/>
-            </a:pPr>
-            <a:r>
-              <a:t>GET /api/v1/health — deployment health check</a:t>
-            </a:r>
-          </a:p>
-          <a:p>
-            <a:pPr>
-              <a:spcAft>
-                <a:spcPts val="1000"/>
-              </a:spcAft>
-              <a:defRPr sz="2000"/>
-            </a:pPr>
-            <a:r>
-              <a:t>Dashboard includes extracted fields, financial statement tables, validations, evidence, and raw JSON.</a:t>
+              <a:t>Missing values remain null rather than fabricated.</a:t>
             </a:r>
           </a:p>
         </p:txBody>
@@ -4226,109 +3842,61 @@
       <p:grpSpPr/>
       <p:sp>
         <p:nvSpPr>
-          <p:cNvPr id="2" name="TextBox 1"/>
-          <p:cNvSpPr txBox="1"/>
-          <p:nvPr/>
-        </p:nvSpPr>
-        <p:spPr>
-          <a:xfrm>
-            <a:off x="548640" y="320040"/>
-            <a:ext cx="10972800" cy="640080"/>
-          </a:xfrm>
-          <a:prstGeom prst="rect">
-            <a:avLst/>
-          </a:prstGeom>
-          <a:noFill/>
-        </p:spPr>
-        <p:txBody>
-          <a:bodyPr wrap="none">
-            <a:spAutoFit/>
-          </a:bodyPr>
+          <p:cNvPr id="2" name="Title 1"/>
+          <p:cNvSpPr>
+            <a:spLocks noGrp="1"/>
+          </p:cNvSpPr>
+          <p:nvPr>
+            <p:ph type="title"/>
+          </p:nvPr>
+        </p:nvSpPr>
+        <p:spPr/>
+        <p:txBody>
+          <a:bodyPr/>
+          <a:lstStyle/>
+          <a:p>
+            <a:r>
+              <a:t>Testing and limitation</a:t>
+            </a:r>
+          </a:p>
+        </p:txBody>
+      </p:sp>
+      <p:sp>
+        <p:nvSpPr>
+          <p:cNvPr id="3" name="Content Placeholder 2"/>
+          <p:cNvSpPr>
+            <a:spLocks noGrp="1"/>
+          </p:cNvSpPr>
+          <p:nvPr>
+            <p:ph idx="1"/>
+          </p:nvPr>
+        </p:nvSpPr>
+        <p:spPr/>
+        <p:txBody>
+          <a:bodyPr/>
           <a:lstStyle/>
           <a:p>
             <a:pPr>
-              <a:defRPr sz="2800" b="1"/>
+              <a:defRPr sz="1800"/>
             </a:pPr>
             <a:r>
-              <a:t>8. Quality, Security &amp; Testing</a:t>
-            </a:r>
-          </a:p>
-        </p:txBody>
-      </p:sp>
-      <p:sp>
-        <p:nvSpPr>
-          <p:cNvPr id="3" name="TextBox 2"/>
-          <p:cNvSpPr txBox="1"/>
-          <p:nvPr/>
-        </p:nvSpPr>
-        <p:spPr>
-          <a:xfrm>
-            <a:off x="731520" y="1371600"/>
-            <a:ext cx="10789920" cy="4754880"/>
-          </a:xfrm>
-          <a:prstGeom prst="rect">
-            <a:avLst/>
-          </a:prstGeom>
-          <a:noFill/>
-        </p:spPr>
-        <p:txBody>
-          <a:bodyPr wrap="square">
-            <a:spAutoFit/>
-          </a:bodyPr>
-          <a:lstStyle/>
+              <a:t>31 tests passed, 1 skipped locally after the dynamic/layout/status changes.</a:t>
+            </a:r>
+          </a:p>
           <a:p>
             <a:pPr>
-              <a:spcAft>
-                <a:spcPts val="1000"/>
-              </a:spcAft>
-              <a:defRPr sz="2000"/>
+              <a:defRPr sz="1800"/>
             </a:pPr>
             <a:r>
-              <a:t>15 automated tests pass locally; one optional provider-client test is skipped when the SDK is absent.</a:t>
+              <a:t>The supplied dataset contains real scanned Balance Sheets but not real source documents for Invoice/P&amp;L/Cash Flow.</a:t>
             </a:r>
           </a:p>
           <a:p>
             <a:pPr>
-              <a:spcAft>
-                <a:spcPts val="1000"/>
-              </a:spcAft>
-              <a:defRPr sz="2000"/>
+              <a:defRPr sz="1800"/>
             </a:pPr>
             <a:r>
-              <a:t>Controlled 4xx errors for unsupported, empty, oversized, over-limit, or corrupted uploads.</a:t>
-            </a:r>
-          </a:p>
-          <a:p>
-            <a:pPr>
-              <a:spcAft>
-                <a:spcPts val="1000"/>
-              </a:spcAft>
-              <a:defRPr sz="2000"/>
-            </a:pPr>
-            <a:r>
-              <a:t>No stack traces or secrets are exposed to end users.</a:t>
-            </a:r>
-          </a:p>
-          <a:p>
-            <a:pPr>
-              <a:spcAft>
-                <a:spcPts val="1000"/>
-              </a:spcAft>
-              <a:defRPr sz="2000"/>
-            </a:pPr>
-            <a:r>
-              <a:t>Real API flow verified with the supplied 2020 Balance Sheet: POST, GET, health, and Swagger.</a:t>
-            </a:r>
-          </a:p>
-          <a:p>
-            <a:pPr>
-              <a:spcAft>
-                <a:spcPts val="1000"/>
-              </a:spcAft>
-              <a:defRPr sz="2000"/>
-            </a:pPr>
-            <a:r>
-              <a:t>Real API token removed from .env.example; deployment secrets must be configured outside source control.</a:t>
+              <a:t>The batch2-0499 issue is covered by a 2-D column extraction regression test.</a:t>
             </a:r>
           </a:p>
         </p:txBody>

</xml_diff>

<commit_message>
Implement async processing and polling to prevent timeouts
</commit_message>
<xml_diff>
--- a/docs/solution_presentation.pptx
+++ b/docs/solution_presentation.pptx
@@ -13,10 +13,8 @@
     <p:sldId id="261" r:id="rId12"/>
     <p:sldId id="262" r:id="rId13"/>
     <p:sldId id="263" r:id="rId14"/>
-    <p:sldId id="264" r:id="rId15"/>
-    <p:sldId id="265" r:id="rId16"/>
   </p:sldIdLst>
-  <p:sldSz cx="12191695" cy="6858000" type="screen4x3"/>
+  <p:sldSz cx="9144000" cy="6858000" type="screen4x3"/>
   <p:notesSz cx="6858000" cy="9144000"/>
   <p:defaultTextStyle>
     <a:defPPr>
@@ -3113,7 +3111,7 @@
           <a:lstStyle/>
           <a:p>
             <a:r>
-              <a:t>Document Intelligence Platform</a:t>
+              <a:t>Intelligent Document Extraction Platform</a:t>
             </a:r>
           </a:p>
         </p:txBody>
@@ -3133,122 +3131,13 @@
           <a:bodyPr/>
           <a:lstStyle/>
           <a:p>
-            <a:pPr>
-              <a:defRPr sz="2000"/>
-            </a:pPr>
             <a:r>
               <a:t>AI Engineer Internship Case Study</a:t>
             </a:r>
           </a:p>
           <a:p>
-            <a:pPr>
-              <a:defRPr sz="1800"/>
-            </a:pPr>
-            <a:r>
-              <a:t>Dynamic extraction for Invoice, Balance Sheet, Profit &amp; Loss, and Cash Flow Statement.</a:t>
-            </a:r>
-          </a:p>
-          <a:p>
-            <a:pPr>
-              <a:defRPr sz="1800"/>
-            </a:pPr>
-            <a:r>
-              <a:t>OCR • 2-D layout • dynamic fields • grounded LLM • validation • SQLite • REST API • dashboard</a:t>
-            </a:r>
-          </a:p>
-        </p:txBody>
-      </p:sp>
-    </p:spTree>
-  </p:cSld>
-  <p:clrMapOvr>
-    <a:masterClrMapping/>
-  </p:clrMapOvr>
-</p:sld>
-</file>
-
-<file path=ppt/slides/slide10.xml><?xml version="1.0" encoding="utf-8"?>
-<p:sld xmlns:a="http://schemas.openxmlformats.org/drawingml/2006/main" xmlns:p="http://schemas.openxmlformats.org/presentationml/2006/main" xmlns:r="http://schemas.openxmlformats.org/officeDocument/2006/relationships">
-  <p:cSld>
-    <p:spTree>
-      <p:nvGrpSpPr>
-        <p:cNvPr id="1" name=""/>
-        <p:cNvGrpSpPr/>
-        <p:nvPr/>
-      </p:nvGrpSpPr>
-      <p:grpSpPr/>
-      <p:sp>
-        <p:nvSpPr>
-          <p:cNvPr id="2" name="Title 1"/>
-          <p:cNvSpPr>
-            <a:spLocks noGrp="1"/>
-          </p:cNvSpPr>
-          <p:nvPr>
-            <p:ph type="title"/>
-          </p:nvPr>
-        </p:nvSpPr>
-        <p:spPr/>
-        <p:txBody>
-          <a:bodyPr/>
-          <a:lstStyle/>
-          <a:p>
-            <a:r>
-              <a:t>Deliverables</a:t>
-            </a:r>
-          </a:p>
-        </p:txBody>
-      </p:sp>
-      <p:sp>
-        <p:nvSpPr>
-          <p:cNvPr id="3" name="Content Placeholder 2"/>
-          <p:cNvSpPr>
-            <a:spLocks noGrp="1"/>
-          </p:cNvSpPr>
-          <p:nvPr>
-            <p:ph idx="1"/>
-          </p:nvPr>
-        </p:nvSpPr>
-        <p:spPr/>
-        <p:txBody>
-          <a:bodyPr/>
-          <a:lstStyle/>
-          <a:p>
-            <a:pPr>
-              <a:defRPr sz="1800"/>
-            </a:pPr>
-            <a:r>
-              <a:t>Dynamic source code and layout-aware OCR</a:t>
-            </a:r>
-          </a:p>
-          <a:p>
-            <a:pPr>
-              <a:defRPr sz="1800"/>
-            </a:pPr>
-            <a:r>
-              <a:t>Architecture diagram and technical audit</a:t>
-            </a:r>
-          </a:p>
-          <a:p>
-            <a:pPr>
-              <a:defRPr sz="1800"/>
-            </a:pPr>
-            <a:r>
-              <a:t>Solution presentation (PPTX and PDF)</a:t>
-            </a:r>
-          </a:p>
-          <a:p>
-            <a:pPr>
-              <a:defRPr sz="1800"/>
-            </a:pPr>
-            <a:r>
-              <a:t>Automated tests</a:t>
-            </a:r>
-          </a:p>
-          <a:p>
-            <a:pPr>
-              <a:defRPr sz="1800"/>
-            </a:pPr>
-            <a:r>
-              <a:t>README with setup, API, validation, and deployment guidance</a:t>
+            <a:r>
+              <a:t>From Design to Deployment</a:t>
             </a:r>
           </a:p>
         </p:txBody>
@@ -3287,7 +3176,7 @@
           <a:lstStyle/>
           <a:p>
             <a:r>
-              <a:t>Problem and design goal</a:t>
+              <a:t>1. Architecture &amp; Design Strategy</a:t>
             </a:r>
           </a:p>
         </p:txBody>
@@ -3307,27 +3196,23 @@
           <a:bodyPr/>
           <a:lstStyle/>
           <a:p>
-            <a:pPr>
-              <a:defRPr sz="1800"/>
-            </a:pPr>
-            <a:r>
-              <a:t>Avoid vendor/template-specific parsers and growing regex/if-else rules.</a:t>
-            </a:r>
-          </a:p>
-          <a:p>
-            <a:pPr>
-              <a:defRPr sz="1800"/>
-            </a:pPr>
-            <a:r>
-              <a:t>Handle different labels, layouts, table positions, headers, footers, and wrapped descriptions.</a:t>
-            </a:r>
-          </a:p>
-          <a:p>
-            <a:pPr>
-              <a:defRPr sz="1800"/>
-            </a:pPr>
-            <a:r>
-              <a:t>Separate document processing status from financial validation status.</a:t>
+            <a:r>
+              <a:t>Goal: Build a robust platform to extract, validate, and store financial documents without rigid templates.</a:t>
+            </a:r>
+          </a:p>
+          <a:p>
+            <a:r>
+              <a:t>Monolithic Design: FastAPI handles both the REST API and serves the Jinja2 HTML Dashboard for simplicity.</a:t>
+            </a:r>
+          </a:p>
+          <a:p>
+            <a:r>
+              <a:t>Dual-Layer Extraction: Uses fast, free OCR/PyMuPDF natively, with an intelligent LLM layer applied dynamically.</a:t>
+            </a:r>
+          </a:p>
+          <a:p>
+            <a:r>
+              <a:t>Persistence: SQLite caches the massive JSON results so the dashboard loads instantly.</a:t>
             </a:r>
           </a:p>
         </p:txBody>
@@ -3366,7 +3251,7 @@
           <a:lstStyle/>
           <a:p>
             <a:r>
-              <a:t>Dynamic processing pipeline</a:t>
+              <a:t>2. Core Technology Stack</a:t>
             </a:r>
           </a:p>
         </p:txBody>
@@ -3386,19 +3271,28 @@
           <a:bodyPr/>
           <a:lstStyle/>
           <a:p>
-            <a:pPr>
-              <a:defRPr sz="1800"/>
-            </a:pPr>
-            <a:r>
-              <a:t>Upload → file validation → native text/OCR → 2-D layout extraction → dynamic semantic extraction → evidence verification → financial validation → persistence → dashboard/API</a:t>
-            </a:r>
-          </a:p>
-          <a:p>
-            <a:pPr>
-              <a:defRPr sz="1800"/>
-            </a:pPr>
-            <a:r>
-              <a:t>OCR retains word coordinates so invoice columns are not flattened into a single text stream.</a:t>
+            <a:r>
+              <a:t>Backend Framework: FastAPI &amp; Python 3.11</a:t>
+            </a:r>
+          </a:p>
+          <a:p>
+            <a:r>
+              <a:t>Frontend: HTML5, CSS3, Vanilla JS, Jinja2 Templates</a:t>
+            </a:r>
+          </a:p>
+          <a:p>
+            <a:r>
+              <a:t>Database: SQLite with SQLAlchemy ORM</a:t>
+            </a:r>
+          </a:p>
+          <a:p>
+            <a:r>
+              <a:t>Document Parsing: PyMuPDF (native PDF text) &amp; Tesseract (OCR for JPG/PNG)</a:t>
+            </a:r>
+          </a:p>
+          <a:p>
+            <a:r>
+              <a:t>AI Integration: Hugging Face (Qwen/Llama) &amp; Google Gemini APIs</a:t>
             </a:r>
           </a:p>
         </p:txBody>
@@ -3437,7 +3331,7 @@
           <a:lstStyle/>
           <a:p>
             <a:r>
-              <a:t>Layout-aware invoice extraction</a:t>
+              <a:t>3. The Extraction Pipeline</a:t>
             </a:r>
           </a:p>
         </p:txBody>
@@ -3457,27 +3351,23 @@
           <a:bodyPr/>
           <a:lstStyle/>
           <a:p>
-            <a:pPr>
-              <a:defRPr sz="1800"/>
-            </a:pPr>
-            <a:r>
-              <a:t>Infer Description / Quantity / Unit Price / Amount columns from actual header positions.</a:t>
-            </a:r>
-          </a:p>
-          <a:p>
-            <a:pPr>
-              <a:defRPr sz="1800"/>
-            </a:pPr>
-            <a:r>
-              <a:t>Numbers inside product descriptions such as 3M 570, 12oz, and 100/BX remain in the description column.</a:t>
-            </a:r>
-          </a:p>
-          <a:p>
-            <a:pPr>
-              <a:defRPr sz="1800"/>
-            </a:pPr>
-            <a:r>
-              <a:t>Wrapped description rows can be buffered and merged without stealing values from adjacent numeric columns.</a:t>
+            <a:r>
+              <a:t>Step 1: Ingestion &amp; Validation (Rejects invalid formats/corrupted files).</a:t>
+            </a:r>
+          </a:p>
+          <a:p>
+            <a:r>
+              <a:t>Step 2: Native Parsing / OCR. System identifies text layout, coordinates, and builds an anchor map.</a:t>
+            </a:r>
+          </a:p>
+          <a:p>
+            <a:r>
+              <a:t>Step 3: Grounded AI Pass. The extracted text array is fed to an LLM via a strict prompt requiring valid JSON output.</a:t>
+            </a:r>
+          </a:p>
+          <a:p>
+            <a:r>
+              <a:t>Step 4: Evidence Mapping. Every extracted value is mapped back to the raw source text to prove it wasn't hallucinated.</a:t>
             </a:r>
           </a:p>
         </p:txBody>
@@ -3516,7 +3406,7 @@
           <a:lstStyle/>
           <a:p>
             <a:r>
-              <a:t>Dynamic fields and LLM grounding</a:t>
+              <a:t>4. Financial Validation Rules</a:t>
             </a:r>
           </a:p>
         </p:txBody>
@@ -3536,35 +3426,33 @@
           <a:bodyPr/>
           <a:lstStyle/>
           <a:p>
-            <a:pPr>
-              <a:defRPr sz="1800"/>
-            </a:pPr>
-            <a:r>
-              <a:t>Canonical fields support required financial validation concepts.</a:t>
-            </a:r>
-          </a:p>
-          <a:p>
-            <a:pPr>
-              <a:defRPr sz="1800"/>
-            </a:pPr>
-            <a:r>
-              <a:t>Unknown meaningful fields are preserved in discovered_fields.</a:t>
-            </a:r>
-          </a:p>
-          <a:p>
-            <a:pPr>
-              <a:defRPr sz="1800"/>
-            </a:pPr>
-            <a:r>
-              <a:t>LLM receives the full OCR document, including header, right-side content, footer, and all pages.</a:t>
-            </a:r>
-          </a:p>
-          <a:p>
-            <a:pPr>
-              <a:defRPr sz="1800"/>
-            </a:pPr>
-            <a:r>
-              <a:t>LLM values are accepted only when grounded in supplied OCR evidence.</a:t>
+            <a:r>
+              <a:t>The application implements strict mathematical reconciliation to catch OCR or LLM errors.</a:t>
+            </a:r>
+          </a:p>
+          <a:p>
+            <a:r>
+              <a:t>Invoices: Subtotal + Tax = Total (Line item math is also verified).</a:t>
+            </a:r>
+          </a:p>
+          <a:p>
+            <a:r>
+              <a:t>Balance Sheets: Assets = Liabilities + Capital.</a:t>
+            </a:r>
+          </a:p>
+          <a:p>
+            <a:r>
+              <a:t>Profit &amp; Loss: Income - Expenses = Net Profit.</a:t>
+            </a:r>
+          </a:p>
+          <a:p>
+            <a:r>
+              <a:t>Cash Flows: Opening Balance + Net Change = Closing Balance.</a:t>
+            </a:r>
+          </a:p>
+          <a:p>
+            <a:r>
+              <a:t>Note: A small float tolerance is applied to account for rounding.</a:t>
             </a:r>
           </a:p>
         </p:txBody>
@@ -3603,7 +3491,7 @@
           <a:lstStyle/>
           <a:p>
             <a:r>
-              <a:t>Invoice validation</a:t>
+              <a:t>5. API &amp; Frontend Dashboard</a:t>
             </a:r>
           </a:p>
         </p:txBody>
@@ -3623,35 +3511,33 @@
           <a:bodyPr/>
           <a:lstStyle/>
           <a:p>
-            <a:pPr>
-              <a:defRPr sz="1800"/>
-            </a:pPr>
-            <a:r>
-              <a:t>Total formula: subtotal + tax + shipping/handling/other charges − discount ≈ total.</a:t>
-            </a:r>
-          </a:p>
-          <a:p>
-            <a:pPr>
-              <a:defRPr sz="1800"/>
-            </a:pPr>
-            <a:r>
-              <a:t>Line-item quantity × unit price ≈ amount.</a:t>
-            </a:r>
-          </a:p>
-          <a:p>
-            <a:pPr>
-              <a:defRPr sz="1800"/>
-            </a:pPr>
-            <a:r>
-              <a:t>Line-item sum ≈ subtotal.</a:t>
-            </a:r>
-          </a:p>
-          <a:p>
-            <a:pPr>
-              <a:defRPr sz="1800"/>
-            </a:pPr>
-            <a:r>
-              <a:t>Validation discrepancies are isolated in validation.overall_status; a successfully parsed document remains processing_status = PASS.</a:t>
+            <a:r>
+              <a:t>REST API (/api/v1/documents):</a:t>
+            </a:r>
+          </a:p>
+          <a:p>
+            <a:r>
+              <a:t>Strict JSON schemas for output, fully documented via automatic Swagger UI.</a:t>
+            </a:r>
+          </a:p>
+          <a:p>
+            <a:r>
+              <a:t>Frontend Dashboard:</a:t>
+            </a:r>
+          </a:p>
+          <a:p>
+            <a:r>
+              <a:t>Upload interface with drag-and-drop.</a:t>
+            </a:r>
+          </a:p>
+          <a:p>
+            <a:r>
+              <a:t>Real-time list of processed documents loaded from SQLite.</a:t>
+            </a:r>
+          </a:p>
+          <a:p>
+            <a:r>
+              <a:t>Detailed view showing evidence grounding, math validation failures (in red), and the raw JSON payload.</a:t>
             </a:r>
           </a:p>
         </p:txBody>
@@ -3690,7 +3576,7 @@
           <a:lstStyle/>
           <a:p>
             <a:r>
-              <a:t>Statement validation</a:t>
+              <a:t>6. Cloud Deployment (Render)</a:t>
             </a:r>
           </a:p>
         </p:txBody>
@@ -3710,27 +3596,23 @@
           <a:bodyPr/>
           <a:lstStyle/>
           <a:p>
-            <a:pPr>
-              <a:defRPr sz="1800"/>
-            </a:pPr>
-            <a:r>
-              <a:t>Balance Sheet: total capital/liabilities ≈ total assets; component reconciliations where sufficient data exists.</a:t>
-            </a:r>
-          </a:p>
-          <a:p>
-            <a:pPr>
-              <a:defRPr sz="1800"/>
-            </a:pPr>
-            <a:r>
-              <a:t>P&amp;L: assignment formulas for bank-style and generic statements.</a:t>
-            </a:r>
-          </a:p>
-          <a:p>
-            <a:pPr>
-              <a:defRPr sz="1800"/>
-            </a:pPr>
-            <a:r>
-              <a:t>Cash Flow: operating + investing + financing + FX ≈ net change; opening + net change + adjustments ≈ closing.</a:t>
+            <a:r>
+              <a:t>The application is deployed on Render.com.</a:t>
+            </a:r>
+          </a:p>
+          <a:p>
+            <a:r>
+              <a:t>Dockerized Environment: We utilize a custom Dockerfile to ensure Tesseract-OCR is installed at the system level.</a:t>
+            </a:r>
+          </a:p>
+          <a:p>
+            <a:r>
+              <a:t>Environment Variables: Secrets like HUGGINGFACE_API_KEY are securely managed in the cloud.</a:t>
+            </a:r>
+          </a:p>
+          <a:p>
+            <a:r>
+              <a:t>CI/CD: GitHub integration automatically redeploys the container when code is pushed to the main branch.</a:t>
             </a:r>
           </a:p>
         </p:txBody>
@@ -3769,7 +3651,7 @@
           <a:lstStyle/>
           <a:p>
             <a:r>
-              <a:t>API, frontend and persistence</a:t>
+              <a:t>7. Future Production Scaling</a:t>
             </a:r>
           </a:p>
         </p:txBody>
@@ -3789,114 +3671,18 @@
           <a:bodyPr/>
           <a:lstStyle/>
           <a:p>
-            <a:pPr>
-              <a:defRPr sz="1800"/>
-            </a:pPr>
-            <a:r>
-              <a:t>FastAPI REST endpoints for process, list, detail, and health.</a:t>
-            </a:r>
-          </a:p>
-          <a:p>
-            <a:pPr>
-              <a:defRPr sz="1800"/>
-            </a:pPr>
-            <a:r>
-              <a:t>SQLite persistence for processed results.</a:t>
-            </a:r>
-          </a:p>
-          <a:p>
-            <a:pPr>
-              <a:defRPr sz="1800"/>
-            </a:pPr>
-            <a:r>
-              <a:t>Dashboard shows extracted fields, evidence, discovered fields, line items, validation checks, and raw JSON.</a:t>
-            </a:r>
-          </a:p>
-          <a:p>
-            <a:pPr>
-              <a:defRPr sz="1800"/>
-            </a:pPr>
-            <a:r>
-              <a:t>Missing values remain null rather than fabricated.</a:t>
-            </a:r>
-          </a:p>
-        </p:txBody>
-      </p:sp>
-    </p:spTree>
-  </p:cSld>
-  <p:clrMapOvr>
-    <a:masterClrMapping/>
-  </p:clrMapOvr>
-</p:sld>
-</file>
-
-<file path=ppt/slides/slide9.xml><?xml version="1.0" encoding="utf-8"?>
-<p:sld xmlns:a="http://schemas.openxmlformats.org/drawingml/2006/main" xmlns:p="http://schemas.openxmlformats.org/presentationml/2006/main" xmlns:r="http://schemas.openxmlformats.org/officeDocument/2006/relationships">
-  <p:cSld>
-    <p:spTree>
-      <p:nvGrpSpPr>
-        <p:cNvPr id="1" name=""/>
-        <p:cNvGrpSpPr/>
-        <p:nvPr/>
-      </p:nvGrpSpPr>
-      <p:grpSpPr/>
-      <p:sp>
-        <p:nvSpPr>
-          <p:cNvPr id="2" name="Title 1"/>
-          <p:cNvSpPr>
-            <a:spLocks noGrp="1"/>
-          </p:cNvSpPr>
-          <p:nvPr>
-            <p:ph type="title"/>
-          </p:nvPr>
-        </p:nvSpPr>
-        <p:spPr/>
-        <p:txBody>
-          <a:bodyPr/>
-          <a:lstStyle/>
-          <a:p>
-            <a:r>
-              <a:t>Testing and limitation</a:t>
-            </a:r>
-          </a:p>
-        </p:txBody>
-      </p:sp>
-      <p:sp>
-        <p:nvSpPr>
-          <p:cNvPr id="3" name="Content Placeholder 2"/>
-          <p:cNvSpPr>
-            <a:spLocks noGrp="1"/>
-          </p:cNvSpPr>
-          <p:nvPr>
-            <p:ph idx="1"/>
-          </p:nvPr>
-        </p:nvSpPr>
-        <p:spPr/>
-        <p:txBody>
-          <a:bodyPr/>
-          <a:lstStyle/>
-          <a:p>
-            <a:pPr>
-              <a:defRPr sz="1800"/>
-            </a:pPr>
-            <a:r>
-              <a:t>31 tests passed, 1 skipped locally after the dynamic/layout/status changes.</a:t>
-            </a:r>
-          </a:p>
-          <a:p>
-            <a:pPr>
-              <a:defRPr sz="1800"/>
-            </a:pPr>
-            <a:r>
-              <a:t>The supplied dataset contains real scanned Balance Sheets but not real source documents for Invoice/P&amp;L/Cash Flow.</a:t>
-            </a:r>
-          </a:p>
-          <a:p>
-            <a:pPr>
-              <a:defRPr sz="1800"/>
-            </a:pPr>
-            <a:r>
-              <a:t>The batch2-0499 issue is covered by a 2-D column extraction regression test.</a:t>
+            <a:r>
+              <a:t>Switch to Async Task Queues (Celery/Redis) to prevent HTTP timeouts on massive 100-page documents.</a:t>
+            </a:r>
+          </a:p>
+          <a:p>
+            <a:r>
+              <a:t>Migrate from SQLite to PostgreSQL to handle high-concurrency database writes.</a:t>
+            </a:r>
+          </a:p>
+          <a:p>
+            <a:r>
+              <a:t>Store document files in AWS S3 or Google Cloud Storage rather than keeping them in base64/memory.</a:t>
             </a:r>
           </a:p>
         </p:txBody>

</xml_diff>